<commit_message>
Fix leftover 6-part wording and drop dual product naming
Part 1's speaker notes and part 2's roadmap-slide header still said
"6 parts" from before the series was trimmed to 5. Also removed the
"Синапс.Инсайт" alternate-name mentions in part 2 (title slide, its
notes, and the identity badge on slide 3) so the deck refers to the
platform only as "Камерата".

Co-Authored-By: Claude Sonnet 5 <noreply@anthropic.com>
Claude-Session: https://claude.ai/code/session_01DpSN8JwCJ3tg3JVUadr2zE
</commit_message>
<xml_diff>
--- a/docs/presentations/02-platforma-arhitektura.pptx
+++ b/docs/presentations/02-platforma-arhitektura.pptx
@@ -526,7 +526,7 @@
           <a:p>
             <a:r>
               <a:rPr lang="en-US" dirty="0"/>
-              <a:t>Титульный слайд курса из 5 частей. Часть 2 посвящена не технологии как таковой (это было в части 1 — LLM, RAG, векторный поиск), а тому, как эта технология упакована в конкретный продукт: интерфейс платформы «Камерата», она же в части источников называется «Синапс.Инсайт» — это два названия одной и той же системы, встречающиеся в разных документах и на разных экранах. Ряд из 11 кружков внизу — это ровно те 11 пунктов левого меню платформы, которые последовательно разбираются в этой колоде: Чат, Мои шаблоны, Источники, Задачи, Калибровка, Управление данными, Каталог, Агенты, Администрирование, База секретов, Мониторинг. Для самостоятельного изучения: держите открытым README базы знаний платформы (docs/platform/README.md) — там та же структура меню с ссылками на детальные статьи по каждому разделу, использованные как первичный источник для этой колоды.</a:t>
+              <a:t>Титульный слайд курса из 5 частей. Часть 2 посвящена не технологии как таковой (это было в части 1 — LLM, RAG, векторный поиск), а тому, как эта технология упакована в конкретный продукт: интерфейс платформы «Камерата». Ряд из 11 кружков внизу — это ровно те 11 пунктов левого меню платформы, которые последовательно разбираются в этой колоде: Чат, Мои шаблоны, Источники, Задачи, Калибровка, Управление данными, Каталог, Агенты, Администрирование, База секретов, Мониторинг. Для самостоятельного изучения: держите открытым README базы знаний платформы (docs/platform/README.md) — там та же структура меню с ссылками на детальные статьи по каждому разделу, использованные как первичный источник для этой колоды.</a:t>
             </a:r>
             <a:endParaRPr lang="en-US" dirty="0"/>
           </a:p>
@@ -2110,7 +2110,7 @@
           <a:p>
             <a:r>
               <a:rPr lang="en-US" dirty="0"/>
-              <a:t>«Камерата» и «Синапс.Инсайт» — не два разных продукта, а два названия одной платформы; в служебной документации встречаются оба. Происхождение имени «Камерата» символично: во Флоренции конца XVI века так называли собрание музыкантов и учёных, из опытов которого выросла опера — не один солист, а ансамбль исполнителей, каждый со своей партией. Платформа устроена похоже: за одним ответом стоит не одна модель, а несколько узких агентов и оркестратор, сводящий их работу воедино (этот образ разворачивается подробнее на слайде про раздел «Агенты»). Ключевое отличие от обычного публичного чат-бота — не в качестве текста, а в источнике истины: сначала поиск по данным компании, потом ответ, с обязательной ссылкой на источник, и явным «не найдено», если ответа в данных нет, вместо уверенной выдумки.</a:t>
+              <a:t>Происхождение имени «Камерата» символично: во Флоренции конца XVI века так называли собрание музыкантов и учёных, из опытов которого выросла опера — не один солист, а ансамбль исполнителей, каждый со своей партией. Платформа устроена похоже: за одним ответом стоит не одна модель, а несколько узких агентов и оркестратор, сводящий их работу воедино (этот образ разворачивается подробнее на слайде про раздел «Агенты»). Ключевое отличие от обычного публичного чат-бота — не в качестве текста, а в источнике истины: сначала поиск по данным компании, потом ответ, с обязательной ссылкой на источник, и явным «не найдено», если ответа в данных нет, вместо уверенной выдумки.</a:t>
             </a:r>
             <a:endParaRPr lang="en-US" dirty="0"/>
           </a:p>
@@ -3150,7 +3150,7 @@
                 <a:ea typeface="Calibri" pitchFamily="34" charset="-122"/>
                 <a:cs typeface="Calibri" pitchFamily="34" charset="-120"/>
               </a:rPr>
-              <a:t>Как технология RAG из части 1 упакована в реальный продукт: разделы левого меню, экраны и рабочие процессы конкретной платформы — «Камерата», она же «Синапс.Инсайт».</a:t>
+              <a:t>Как технология RAG из части 1 упакована в реальный продукт: разделы левого меню, экраны и рабочие процессы конкретной платформы «Камерата».</a:t>
             </a:r>
             <a:endParaRPr lang="en-US" sz="1550" dirty="0"/>
           </a:p>
@@ -15616,7 +15616,7 @@
                 <a:ea typeface="Cambria" pitchFamily="34" charset="-122"/>
                 <a:cs typeface="Cambria" pitchFamily="34" charset="-120"/>
               </a:rPr>
-              <a:t>Шесть частей одного курса</a:t>
+              <a:t>Пять частей одного курса</a:t>
             </a:r>
             <a:endParaRPr lang="en-US" sz="3000" dirty="0"/>
           </a:p>
@@ -24652,7 +24652,7 @@
         </p:nvSpPr>
         <p:spPr>
           <a:xfrm>
-            <a:off x="548640" y="3703320"/>
+            <a:off x="1956816" y="3703320"/>
             <a:ext cx="2670048" cy="777240"/>
           </a:xfrm>
           <a:prstGeom prst="roundRect">
@@ -24686,7 +24686,7 @@
         </p:nvSpPr>
         <p:spPr>
           <a:xfrm>
-            <a:off x="548640" y="3813048"/>
+            <a:off x="1956816" y="3813048"/>
             <a:ext cx="2670048" cy="320040"/>
           </a:xfrm>
           <a:prstGeom prst="rect">
@@ -24725,7 +24725,7 @@
         </p:nvSpPr>
         <p:spPr>
           <a:xfrm>
-            <a:off x="548640" y="4160520"/>
+            <a:off x="1956816" y="4160520"/>
             <a:ext cx="2670048" cy="256032"/>
           </a:xfrm>
           <a:prstGeom prst="rect">
@@ -24751,118 +24751,6 @@
                 <a:cs typeface="Calibri" pitchFamily="34" charset="-120"/>
               </a:rPr>
               <a:t>имя из мира культуры</a:t>
-            </a:r>
-            <a:endParaRPr lang="en-US" sz="1000" dirty="0"/>
-          </a:p>
-        </p:txBody>
-      </p:sp>
-      <p:sp>
-        <p:nvSpPr>
-          <p:cNvPr id="13" name="Shape 11"/>
-          <p:cNvSpPr/>
-          <p:nvPr/>
-        </p:nvSpPr>
-        <p:spPr>
-          <a:xfrm>
-            <a:off x="3364992" y="3703320"/>
-            <a:ext cx="2670048" cy="777240"/>
-          </a:xfrm>
-          <a:prstGeom prst="roundRect">
-            <a:avLst>
-              <a:gd name="adj" fmla="val 10588"/>
-            </a:avLst>
-          </a:prstGeom>
-          <a:solidFill>
-            <a:srgbClr val="36454F"/>
-          </a:solidFill>
-          <a:ln w="12700">
-            <a:solidFill>
-              <a:srgbClr val="DADFE3"/>
-            </a:solidFill>
-            <a:prstDash val="solid"/>
-          </a:ln>
-          <a:effectLst>
-            <a:outerShdw sx="100000" sy="100000" kx="0" ky="0" algn="bl" rotWithShape="0" blurRad="101600" dist="25400" dir="5400000">
-              <a:srgbClr val="1B1F23">
-                <a:alpha val="12000"/>
-              </a:srgbClr>
-            </a:outerShdw>
-          </a:effectLst>
-        </p:spPr>
-      </p:sp>
-      <p:sp>
-        <p:nvSpPr>
-          <p:cNvPr id="14" name="Text 12"/>
-          <p:cNvSpPr txBox="1"/>
-          <p:nvPr/>
-        </p:nvSpPr>
-        <p:spPr>
-          <a:xfrm>
-            <a:off x="3364992" y="3813048"/>
-            <a:ext cx="2670048" cy="320040"/>
-          </a:xfrm>
-          <a:prstGeom prst="rect">
-            <a:avLst/>
-          </a:prstGeom>
-          <a:noFill/>
-          <a:ln/>
-        </p:spPr>
-        <p:txBody>
-          <a:bodyPr wrap="square" lIns="0" tIns="0" rIns="0" bIns="0" rtlCol="0" anchor="ctr"/>
-          <a:lstStyle/>
-          <a:p>
-            <a:pPr algn="ctr" indent="0" marL="0">
-              <a:buNone/>
-            </a:pPr>
-            <a:r>
-              <a:rPr lang="en-US" sz="1500" b="1" dirty="0">
-                <a:solidFill>
-                  <a:srgbClr val="FFFFFF"/>
-                </a:solidFill>
-                <a:latin typeface="Cambria" pitchFamily="34" charset="0"/>
-                <a:ea typeface="Cambria" pitchFamily="34" charset="-122"/>
-                <a:cs typeface="Cambria" pitchFamily="34" charset="-120"/>
-              </a:rPr>
-              <a:t>«Синапс.Инсайт»</a:t>
-            </a:r>
-            <a:endParaRPr lang="en-US" sz="1500" dirty="0"/>
-          </a:p>
-        </p:txBody>
-      </p:sp>
-      <p:sp>
-        <p:nvSpPr>
-          <p:cNvPr id="15" name="Text 13"/>
-          <p:cNvSpPr txBox="1"/>
-          <p:nvPr/>
-        </p:nvSpPr>
-        <p:spPr>
-          <a:xfrm>
-            <a:off x="3364992" y="4160520"/>
-            <a:ext cx="2670048" cy="256032"/>
-          </a:xfrm>
-          <a:prstGeom prst="rect">
-            <a:avLst/>
-          </a:prstGeom>
-          <a:noFill/>
-          <a:ln/>
-        </p:spPr>
-        <p:txBody>
-          <a:bodyPr wrap="square" lIns="0" tIns="0" rIns="0" bIns="0" rtlCol="0" anchor="ctr"/>
-          <a:lstStyle/>
-          <a:p>
-            <a:pPr algn="ctr" indent="0" marL="0">
-              <a:buNone/>
-            </a:pPr>
-            <a:r>
-              <a:rPr lang="en-US" sz="1000" dirty="0">
-                <a:solidFill>
-                  <a:srgbClr val="AEB8C2"/>
-                </a:solidFill>
-                <a:latin typeface="Calibri" pitchFamily="34" charset="0"/>
-                <a:ea typeface="Calibri" pitchFamily="34" charset="-122"/>
-                <a:cs typeface="Calibri" pitchFamily="34" charset="-120"/>
-              </a:rPr>
-              <a:t>техническое / рабочее имя</a:t>
             </a:r>
             <a:endParaRPr lang="en-US" sz="1000" dirty="0"/>
           </a:p>
@@ -24889,7 +24777,7 @@
           <a:bodyPr wrap="square" lIns="0" tIns="0" rIns="0" bIns="0" rtlCol="0" anchor="t"/>
           <a:lstStyle/>
           <a:p>
-            <a:pPr indent="0" marL="0">
+            <a:pPr algn="ctr" indent="0" marL="0">
               <a:buNone/>
             </a:pPr>
             <a:r>
@@ -24901,7 +24789,7 @@
                 <a:ea typeface="Calibri" pitchFamily="34" charset="-122"/>
                 <a:cs typeface="Calibri" pitchFamily="34" charset="-120"/>
               </a:rPr>
-              <a:t>Два названия одной и той же системы — встречаются в разных документах и на разных экранах.</a:t>
+              <a:t>Название отсылает к флорентийской камерате XVI века — собранию музыкантов и учёных, породившему оперу.</a:t>
             </a:r>
             <a:endParaRPr lang="en-US" sz="1050" dirty="0"/>
           </a:p>

</xml_diff>

<commit_message>
Add plain-language description to part 2's roadmap slide
Slide 2 previously jumped straight from the title to the 5-item list
with no explanation of what the roadmap represents.

Co-Authored-By: Claude Sonnet 5 <noreply@anthropic.com>
Claude-Session: https://claude.ai/code/session_01DpSN8JwCJ3tg3JVUadr2zE
</commit_message>
<xml_diff>
--- a/docs/presentations/02-platforma-arhitektura.pptx
+++ b/docs/presentations/02-platforma-arhitektura.pptx
@@ -15624,6 +15624,45 @@
       </p:sp>
       <p:sp>
         <p:nvSpPr>
+          <p:cNvPr id="35" name="Text Subtitle"/>
+          <p:cNvSpPr txBox="1"/>
+          <p:nvPr/>
+        </p:nvSpPr>
+        <p:spPr>
+          <a:xfrm>
+            <a:off x="548640" y="1298448"/>
+            <a:ext cx="11094415" cy="228600"/>
+          </a:xfrm>
+          <a:prstGeom prst="rect">
+            <a:avLst/>
+          </a:prstGeom>
+          <a:noFill/>
+          <a:ln/>
+        </p:spPr>
+        <p:txBody>
+          <a:bodyPr wrap="square" lIns="0" tIns="0" rIns="0" bIns="0" rtlCol="0" anchor="t"/>
+          <a:lstStyle/>
+          <a:p>
+            <a:pPr indent="0" marL="0">
+              <a:buNone/>
+            </a:pPr>
+            <a:r>
+              <a:rPr lang="en-US" sz="1300" dirty="0">
+                <a:solidFill>
+                  <a:srgbClr val="5C6B7A"/>
+                </a:solidFill>
+                <a:latin typeface="Calibri" pitchFamily="34" charset="0"/>
+                <a:ea typeface="Calibri" pitchFamily="34" charset="-122"/>
+                <a:cs typeface="Calibri" pitchFamily="34" charset="-120"/>
+              </a:rPr>
+              <a:t>Оглавление курса: пять презентаций по порядку, каждая опирается на предыдущую.</a:t>
+            </a:r>
+            <a:endParaRPr lang="en-US" sz="1300" dirty="0"/>
+          </a:p>
+        </p:txBody>
+      </p:sp>
+      <p:sp>
+        <p:nvSpPr>
           <p:cNvPr id="4" name="Text 2"/>
           <p:cNvSpPr txBox="1"/>
           <p:nvPr/>

</xml_diff>

<commit_message>
Add everyday-language analogies throughout part 2
Added a "ПРОСТЫМИ СЛОВАМИ" aside to the platform-overview slide and
each of the 10 menu-section slides, giving a plain household analogy
alongside the existing technical explanation (secretary's template
folder, HR record, a safe, hiring probation, etc.). Slide 17 needed
its two-column layout tightened to make room without overlap.

Co-Authored-By: Claude Sonnet 5 <noreply@anthropic.com>
Claude-Session: https://claude.ai/code/session_01DpSN8JwCJ3tg3JVUadr2zE
</commit_message>
<xml_diff>
--- a/docs/presentations/02-platforma-arhitektura.pptx
+++ b/docs/presentations/02-platforma-arhitektura.pptx
@@ -6576,6 +6576,87 @@
           </a:p>
         </p:txBody>
       </p:sp>
+      <p:sp>
+        <p:nvSpPr>
+          <p:cNvPr id="9001" name="TextAnalogyLabel"/>
+          <p:cNvSpPr txBox="1"/>
+          <p:nvPr/>
+        </p:nvSpPr>
+        <p:spPr>
+          <a:xfrm>
+            <a:off x="548640" y="5836440"/>
+            <a:ext cx="11094415" cy="182880"/>
+          </a:xfrm>
+          <a:prstGeom prst="rect">
+            <a:avLst/>
+          </a:prstGeom>
+          <a:noFill/>
+          <a:ln/>
+        </p:spPr>
+        <p:txBody>
+          <a:bodyPr wrap="square" lIns="0" tIns="0" rIns="0" bIns="0" rtlCol="0" anchor="t"/>
+          <a:lstStyle/>
+          <a:p>
+            <a:pPr indent="0" marL="0">
+              <a:buNone/>
+            </a:pPr>
+            <a:r>
+              <a:rPr lang="en-US" sz="950" b="1" spc="100" kern="0" dirty="0">
+                <a:solidFill>
+                  <a:srgbClr val="0E7A8C"/>
+                </a:solidFill>
+                <a:latin typeface="Calibri" pitchFamily="34" charset="0"/>
+                <a:ea typeface="Calibri" pitchFamily="34" charset="-122"/>
+                <a:cs typeface="Calibri" pitchFamily="34" charset="-120"/>
+              </a:rPr>
+              <a:t>ПРОСТЫМИ СЛОВАМИ</a:t>
+            </a:r>
+            <a:endParaRPr lang="en-US" sz="950" dirty="0"/>
+          </a:p>
+        </p:txBody>
+      </p:sp>
+      <p:sp>
+        <p:nvSpPr>
+          <p:cNvPr id="9002" name="TextAnalogyBody"/>
+          <p:cNvSpPr txBox="1"/>
+          <p:nvPr/>
+        </p:nvSpPr>
+        <p:spPr>
+          <a:xfrm>
+            <a:off x="548640" y="6065040"/>
+            <a:ext cx="11094415" cy="600000"/>
+          </a:xfrm>
+          <a:prstGeom prst="rect">
+            <a:avLst/>
+          </a:prstGeom>
+          <a:noFill/>
+          <a:ln/>
+        </p:spPr>
+        <p:txBody>
+          <a:bodyPr wrap="square" lIns="0" tIns="0" rIns="0" bIns="0" rtlCol="0" anchor="t"/>
+          <a:lstStyle/>
+          <a:p>
+            <a:pPr indent="0" marL="0">
+              <a:lnSpc>
+                <a:spcPts val="1400"/>
+              </a:lnSpc>
+              <a:buNone/>
+            </a:pPr>
+            <a:r>
+              <a:rPr lang="en-US" sz="1100" i="1" dirty="0">
+                <a:solidFill>
+                  <a:srgbClr val="6B7680"/>
+                </a:solidFill>
+                <a:latin typeface="Calibri" pitchFamily="34" charset="0"/>
+                <a:ea typeface="Calibri" pitchFamily="34" charset="-122"/>
+                <a:cs typeface="Calibri" pitchFamily="34" charset="-120"/>
+              </a:rPr>
+              <a:t>Как настройка кофемашины под конкретные зёрна: крутите не программу целиком, а несколько понятных ручек — насколько строго отличать таблицу от текста, что важнее при поиске, куда смотреть, если ответ получился странным.</a:t>
+            </a:r>
+            <a:endParaRPr lang="en-US" sz="1100" dirty="0"/>
+          </a:p>
+        </p:txBody>
+      </p:sp>
     </p:spTree>
   </p:cSld>
   <p:clrMapOvr>
@@ -10339,6 +10420,87 @@
           </a:p>
         </p:txBody>
       </p:sp>
+      <p:sp>
+        <p:nvSpPr>
+          <p:cNvPr id="9001" name="TextAnalogyLabel"/>
+          <p:cNvSpPr txBox="1"/>
+          <p:nvPr/>
+        </p:nvSpPr>
+        <p:spPr>
+          <a:xfrm>
+            <a:off x="548640" y="5857160"/>
+            <a:ext cx="11094415" cy="182880"/>
+          </a:xfrm>
+          <a:prstGeom prst="rect">
+            <a:avLst/>
+          </a:prstGeom>
+          <a:noFill/>
+          <a:ln/>
+        </p:spPr>
+        <p:txBody>
+          <a:bodyPr wrap="square" lIns="0" tIns="0" rIns="0" bIns="0" rtlCol="0" anchor="t"/>
+          <a:lstStyle/>
+          <a:p>
+            <a:pPr indent="0" marL="0">
+              <a:buNone/>
+            </a:pPr>
+            <a:r>
+              <a:rPr lang="en-US" sz="950" b="1" spc="100" kern="0" dirty="0">
+                <a:solidFill>
+                  <a:srgbClr val="0E7A8C"/>
+                </a:solidFill>
+                <a:latin typeface="Calibri" pitchFamily="34" charset="0"/>
+                <a:ea typeface="Calibri" pitchFamily="34" charset="-122"/>
+                <a:cs typeface="Calibri" pitchFamily="34" charset="-120"/>
+              </a:rPr>
+              <a:t>ПРОСТЫМИ СЛОВАМИ</a:t>
+            </a:r>
+            <a:endParaRPr lang="en-US" sz="950" dirty="0"/>
+          </a:p>
+        </p:txBody>
+      </p:sp>
+      <p:sp>
+        <p:nvSpPr>
+          <p:cNvPr id="9002" name="TextAnalogyBody"/>
+          <p:cNvSpPr txBox="1"/>
+          <p:nvPr/>
+        </p:nvSpPr>
+        <p:spPr>
+          <a:xfrm>
+            <a:off x="548640" y="6060040"/>
+            <a:ext cx="11094415" cy="600000"/>
+          </a:xfrm>
+          <a:prstGeom prst="rect">
+            <a:avLst/>
+          </a:prstGeom>
+          <a:noFill/>
+          <a:ln/>
+        </p:spPr>
+        <p:txBody>
+          <a:bodyPr wrap="square" lIns="0" tIns="0" rIns="0" bIns="0" rtlCol="0" anchor="t"/>
+          <a:lstStyle/>
+          <a:p>
+            <a:pPr indent="0" marL="0">
+              <a:lnSpc>
+                <a:spcPts val="1400"/>
+              </a:lnSpc>
+              <a:buNone/>
+            </a:pPr>
+            <a:r>
+              <a:rPr lang="en-US" sz="1100" i="1" dirty="0">
+                <a:solidFill>
+                  <a:srgbClr val="6B7680"/>
+                </a:solidFill>
+                <a:latin typeface="Calibri" pitchFamily="34" charset="0"/>
+                <a:ea typeface="Calibri" pitchFamily="34" charset="-122"/>
+                <a:cs typeface="Calibri" pitchFamily="34" charset="-120"/>
+              </a:rPr>
+              <a:t>Это чертежи здания компании: видно, из чего состоит каждая таблица с данными, как один отчёт получается из другого и кому вообще разрешено туда заходить.</a:t>
+            </a:r>
+            <a:endParaRPr lang="en-US" sz="1100" dirty="0"/>
+          </a:p>
+        </p:txBody>
+      </p:sp>
     </p:spTree>
   </p:cSld>
   <p:clrMapOvr>
@@ -12209,6 +12371,87 @@
           </a:p>
         </p:txBody>
       </p:sp>
+      <p:sp>
+        <p:nvSpPr>
+          <p:cNvPr id="9001" name="TextAnalogyLabel"/>
+          <p:cNvSpPr txBox="1"/>
+          <p:nvPr/>
+        </p:nvSpPr>
+        <p:spPr>
+          <a:xfrm>
+            <a:off x="548640" y="5857160"/>
+            <a:ext cx="11094415" cy="182880"/>
+          </a:xfrm>
+          <a:prstGeom prst="rect">
+            <a:avLst/>
+          </a:prstGeom>
+          <a:noFill/>
+          <a:ln/>
+        </p:spPr>
+        <p:txBody>
+          <a:bodyPr wrap="square" lIns="0" tIns="0" rIns="0" bIns="0" rtlCol="0" anchor="t"/>
+          <a:lstStyle/>
+          <a:p>
+            <a:pPr indent="0" marL="0">
+              <a:buNone/>
+            </a:pPr>
+            <a:r>
+              <a:rPr lang="en-US" sz="950" b="1" spc="100" kern="0" dirty="0">
+                <a:solidFill>
+                  <a:srgbClr val="0E7A8C"/>
+                </a:solidFill>
+                <a:latin typeface="Calibri" pitchFamily="34" charset="0"/>
+                <a:ea typeface="Calibri" pitchFamily="34" charset="-122"/>
+                <a:cs typeface="Calibri" pitchFamily="34" charset="-120"/>
+              </a:rPr>
+              <a:t>ПРОСТЫМИ СЛОВАМИ</a:t>
+            </a:r>
+            <a:endParaRPr lang="en-US" sz="950" dirty="0"/>
+          </a:p>
+        </p:txBody>
+      </p:sp>
+      <p:sp>
+        <p:nvSpPr>
+          <p:cNvPr id="9002" name="TextAnalogyBody"/>
+          <p:cNvSpPr txBox="1"/>
+          <p:nvPr/>
+        </p:nvSpPr>
+        <p:spPr>
+          <a:xfrm>
+            <a:off x="548640" y="6060040"/>
+            <a:ext cx="11094415" cy="600000"/>
+          </a:xfrm>
+          <a:prstGeom prst="rect">
+            <a:avLst/>
+          </a:prstGeom>
+          <a:noFill/>
+          <a:ln/>
+        </p:spPr>
+        <p:txBody>
+          <a:bodyPr wrap="square" lIns="0" tIns="0" rIns="0" bIns="0" rtlCol="0" anchor="t"/>
+          <a:lstStyle/>
+          <a:p>
+            <a:pPr indent="0" marL="0">
+              <a:lnSpc>
+                <a:spcPts val="1400"/>
+              </a:lnSpc>
+              <a:buNone/>
+            </a:pPr>
+            <a:r>
+              <a:rPr lang="en-US" sz="1100" i="1" dirty="0">
+                <a:solidFill>
+                  <a:srgbClr val="6B7680"/>
+                </a:solidFill>
+                <a:latin typeface="Calibri" pitchFamily="34" charset="0"/>
+                <a:ea typeface="Calibri" pitchFamily="34" charset="-122"/>
+                <a:cs typeface="Calibri" pitchFamily="34" charset="-120"/>
+              </a:rPr>
+              <a:t>Как отдел кадров: именно здесь заводится карточка нового сотрудника и его логин — остальные экраны потом просто ссылаются на эту запись, а не заводят человека заново.</a:t>
+            </a:r>
+            <a:endParaRPr lang="en-US" sz="1100" dirty="0"/>
+          </a:p>
+        </p:txBody>
+      </p:sp>
     </p:spTree>
   </p:cSld>
   <p:clrMapOvr>
@@ -12405,8 +12648,8 @@
         </p:nvSpPr>
         <p:spPr>
           <a:xfrm>
-            <a:off x="548640" y="1554480"/>
-            <a:ext cx="5212080" cy="4617720"/>
+            <a:off x="548640" y="1476120"/>
+            <a:ext cx="5212080" cy="4273632"/>
           </a:xfrm>
           <a:prstGeom prst="roundRect">
             <a:avLst>
@@ -12439,7 +12682,7 @@
         </p:nvSpPr>
         <p:spPr>
           <a:xfrm>
-            <a:off x="777240" y="1737360"/>
+            <a:off x="777240" y="1576120"/>
             <a:ext cx="4572000" cy="256032"/>
           </a:xfrm>
           <a:prstGeom prst="rect">
@@ -12478,7 +12721,7 @@
         </p:nvSpPr>
         <p:spPr>
           <a:xfrm>
-            <a:off x="777240" y="2057400"/>
+            <a:off x="777240" y="1872152"/>
             <a:ext cx="4754880" cy="1417320"/>
           </a:xfrm>
           <a:prstGeom prst="roundRect">
@@ -12512,7 +12755,7 @@
         </p:nvSpPr>
         <p:spPr>
           <a:xfrm>
-            <a:off x="960120" y="2194560"/>
+            <a:off x="960120" y="2009312"/>
             <a:ext cx="4389120" cy="320040"/>
           </a:xfrm>
           <a:prstGeom prst="rect">
@@ -12551,7 +12794,7 @@
         </p:nvSpPr>
         <p:spPr>
           <a:xfrm>
-            <a:off x="960120" y="2514600"/>
+            <a:off x="960120" y="2329352"/>
             <a:ext cx="4389120" cy="914400"/>
           </a:xfrm>
           <a:prstGeom prst="rect">
@@ -12593,7 +12836,7 @@
         </p:nvSpPr>
         <p:spPr>
           <a:xfrm>
-            <a:off x="777240" y="3611880"/>
+            <a:off x="777240" y="3379472"/>
             <a:ext cx="4754880" cy="1417320"/>
           </a:xfrm>
           <a:prstGeom prst="roundRect">
@@ -12627,7 +12870,7 @@
         </p:nvSpPr>
         <p:spPr>
           <a:xfrm>
-            <a:off x="960120" y="3749040"/>
+            <a:off x="960120" y="3516632"/>
             <a:ext cx="4389120" cy="320040"/>
           </a:xfrm>
           <a:prstGeom prst="rect">
@@ -12666,7 +12909,7 @@
         </p:nvSpPr>
         <p:spPr>
           <a:xfrm>
-            <a:off x="960120" y="4069080"/>
+            <a:off x="960120" y="3836672"/>
             <a:ext cx="4389120" cy="868680"/>
           </a:xfrm>
           <a:prstGeom prst="rect">
@@ -12708,7 +12951,7 @@
         </p:nvSpPr>
         <p:spPr>
           <a:xfrm>
-            <a:off x="777240" y="5166360"/>
+            <a:off x="777240" y="4886792"/>
             <a:ext cx="4754880" cy="822960"/>
           </a:xfrm>
           <a:prstGeom prst="rect">
@@ -12750,8 +12993,8 @@
         </p:nvSpPr>
         <p:spPr>
           <a:xfrm>
-            <a:off x="5577840" y="1554480"/>
-            <a:ext cx="6062472" cy="4617720"/>
+            <a:off x="5577840" y="1476120"/>
+            <a:ext cx="6062472" cy="4273632"/>
           </a:xfrm>
           <a:prstGeom prst="roundRect">
             <a:avLst>
@@ -12784,7 +13027,7 @@
         </p:nvSpPr>
         <p:spPr>
           <a:xfrm>
-            <a:off x="5806440" y="1737360"/>
+            <a:off x="5806440" y="1659000"/>
             <a:ext cx="5486400" cy="256032"/>
           </a:xfrm>
           <a:prstGeom prst="rect">
@@ -12823,7 +13066,7 @@
         </p:nvSpPr>
         <p:spPr>
           <a:xfrm>
-            <a:off x="5852160" y="2148840"/>
+            <a:off x="5852160" y="2070480"/>
             <a:ext cx="420624" cy="420624"/>
           </a:xfrm>
           <a:prstGeom prst="ellipse">
@@ -12843,7 +13086,7 @@
         </p:nvSpPr>
         <p:spPr>
           <a:xfrm>
-            <a:off x="5852160" y="2148840"/>
+            <a:off x="5852160" y="2070480"/>
             <a:ext cx="420624" cy="420624"/>
           </a:xfrm>
           <a:prstGeom prst="rect">
@@ -12882,7 +13125,7 @@
         </p:nvSpPr>
         <p:spPr>
           <a:xfrm>
-            <a:off x="6400800" y="2112264"/>
+            <a:off x="6400800" y="2033904"/>
             <a:ext cx="5074920" cy="777240"/>
           </a:xfrm>
           <a:prstGeom prst="rect">
@@ -12942,7 +13185,7 @@
         </p:nvSpPr>
         <p:spPr>
           <a:xfrm>
-            <a:off x="6062472" y="2606040"/>
+            <a:off x="6062472" y="2527680"/>
             <a:ext cx="0" cy="320040"/>
           </a:xfrm>
           <a:prstGeom prst="line">
@@ -12965,7 +13208,7 @@
         </p:nvSpPr>
         <p:spPr>
           <a:xfrm>
-            <a:off x="5852160" y="3044952"/>
+            <a:off x="5852160" y="2966592"/>
             <a:ext cx="420624" cy="420624"/>
           </a:xfrm>
           <a:prstGeom prst="ellipse">
@@ -12985,7 +13228,7 @@
         </p:nvSpPr>
         <p:spPr>
           <a:xfrm>
-            <a:off x="5852160" y="3044952"/>
+            <a:off x="5852160" y="2966592"/>
             <a:ext cx="420624" cy="420624"/>
           </a:xfrm>
           <a:prstGeom prst="rect">
@@ -13024,7 +13267,7 @@
         </p:nvSpPr>
         <p:spPr>
           <a:xfrm>
-            <a:off x="6400800" y="3008376"/>
+            <a:off x="6400800" y="2930016"/>
             <a:ext cx="5074920" cy="777240"/>
           </a:xfrm>
           <a:prstGeom prst="rect">
@@ -13084,7 +13327,7 @@
         </p:nvSpPr>
         <p:spPr>
           <a:xfrm>
-            <a:off x="6062472" y="3502152"/>
+            <a:off x="6062472" y="3423792"/>
             <a:ext cx="0" cy="320040"/>
           </a:xfrm>
           <a:prstGeom prst="line">
@@ -13107,7 +13350,7 @@
         </p:nvSpPr>
         <p:spPr>
           <a:xfrm>
-            <a:off x="5852160" y="3941064"/>
+            <a:off x="5852160" y="3862704"/>
             <a:ext cx="420624" cy="420624"/>
           </a:xfrm>
           <a:prstGeom prst="ellipse">
@@ -13127,7 +13370,7 @@
         </p:nvSpPr>
         <p:spPr>
           <a:xfrm>
-            <a:off x="5852160" y="3941064"/>
+            <a:off x="5852160" y="3862704"/>
             <a:ext cx="420624" cy="420624"/>
           </a:xfrm>
           <a:prstGeom prst="rect">
@@ -13166,7 +13409,7 @@
         </p:nvSpPr>
         <p:spPr>
           <a:xfrm>
-            <a:off x="6400800" y="3904488"/>
+            <a:off x="6400800" y="3826128"/>
             <a:ext cx="5074920" cy="777240"/>
           </a:xfrm>
           <a:prstGeom prst="rect">
@@ -13226,7 +13469,7 @@
         </p:nvSpPr>
         <p:spPr>
           <a:xfrm>
-            <a:off x="6062472" y="4398264"/>
+            <a:off x="6062472" y="4319904"/>
             <a:ext cx="0" cy="320040"/>
           </a:xfrm>
           <a:prstGeom prst="line">
@@ -13249,7 +13492,7 @@
         </p:nvSpPr>
         <p:spPr>
           <a:xfrm>
-            <a:off x="5852160" y="4837176"/>
+            <a:off x="5852160" y="4758816"/>
             <a:ext cx="420624" cy="420624"/>
           </a:xfrm>
           <a:prstGeom prst="ellipse">
@@ -13269,7 +13512,7 @@
         </p:nvSpPr>
         <p:spPr>
           <a:xfrm>
-            <a:off x="5852160" y="4837176"/>
+            <a:off x="5852160" y="4758816"/>
             <a:ext cx="420624" cy="420624"/>
           </a:xfrm>
           <a:prstGeom prst="rect">
@@ -13308,7 +13551,7 @@
         </p:nvSpPr>
         <p:spPr>
           <a:xfrm>
-            <a:off x="6400800" y="4800600"/>
+            <a:off x="6400800" y="4722240"/>
             <a:ext cx="5074920" cy="777240"/>
           </a:xfrm>
           <a:prstGeom prst="rect">
@@ -13357,6 +13600,87 @@
               <a:t>агент становится доступен для выбора в чате</a:t>
             </a:r>
             <a:endParaRPr lang="en-US" sz="1250" dirty="0"/>
+          </a:p>
+        </p:txBody>
+      </p:sp>
+      <p:sp>
+        <p:nvSpPr>
+          <p:cNvPr id="9001" name="TextAnalogyLabel"/>
+          <p:cNvSpPr txBox="1"/>
+          <p:nvPr/>
+        </p:nvSpPr>
+        <p:spPr>
+          <a:xfrm>
+            <a:off x="548640" y="5779752"/>
+            <a:ext cx="11094415" cy="182880"/>
+          </a:xfrm>
+          <a:prstGeom prst="rect">
+            <a:avLst/>
+          </a:prstGeom>
+          <a:noFill/>
+          <a:ln/>
+        </p:spPr>
+        <p:txBody>
+          <a:bodyPr wrap="square" lIns="0" tIns="0" rIns="0" bIns="0" rtlCol="0" anchor="t"/>
+          <a:lstStyle/>
+          <a:p>
+            <a:pPr indent="0" marL="0">
+              <a:buNone/>
+            </a:pPr>
+            <a:r>
+              <a:rPr lang="en-US" sz="950" b="1" spc="100" kern="0" dirty="0">
+                <a:solidFill>
+                  <a:srgbClr val="0E7A8C"/>
+                </a:solidFill>
+                <a:latin typeface="Calibri" pitchFamily="34" charset="0"/>
+                <a:ea typeface="Calibri" pitchFamily="34" charset="-122"/>
+                <a:cs typeface="Calibri" pitchFamily="34" charset="-120"/>
+              </a:rPr>
+              <a:t>ПРОСТЫМИ СЛОВАМИ</a:t>
+            </a:r>
+            <a:endParaRPr lang="en-US" sz="950" dirty="0"/>
+          </a:p>
+        </p:txBody>
+      </p:sp>
+      <p:sp>
+        <p:nvSpPr>
+          <p:cNvPr id="9002" name="TextAnalogyBody"/>
+          <p:cNvSpPr txBox="1"/>
+          <p:nvPr/>
+        </p:nvSpPr>
+        <p:spPr>
+          <a:xfrm>
+            <a:off x="548640" y="6008352"/>
+            <a:ext cx="11094415" cy="600000"/>
+          </a:xfrm>
+          <a:prstGeom prst="rect">
+            <a:avLst/>
+          </a:prstGeom>
+          <a:noFill/>
+          <a:ln/>
+        </p:spPr>
+        <p:txBody>
+          <a:bodyPr wrap="square" lIns="0" tIns="0" rIns="0" bIns="0" rtlCol="0" anchor="t"/>
+          <a:lstStyle/>
+          <a:p>
+            <a:pPr indent="0" marL="0">
+              <a:lnSpc>
+                <a:spcPts val="1400"/>
+              </a:lnSpc>
+              <a:buNone/>
+            </a:pPr>
+            <a:r>
+              <a:rPr lang="en-US" sz="1100" i="1" dirty="0">
+                <a:solidFill>
+                  <a:srgbClr val="6B7680"/>
+                </a:solidFill>
+                <a:latin typeface="Calibri" pitchFamily="34" charset="0"/>
+                <a:ea typeface="Calibri" pitchFamily="34" charset="-122"/>
+                <a:cs typeface="Calibri" pitchFamily="34" charset="-120"/>
+              </a:rPr>
+              <a:t>Как найм нового сотрудника на испытательный срок: сначала «конструируют» его обязанности на схеме, потом куратор данных проверяет, что он делает разумные вещи, и только затем ИБ выдаёт окончательный допуск.</a:t>
+            </a:r>
+            <a:endParaRPr lang="en-US" sz="1100" dirty="0"/>
           </a:p>
         </p:txBody>
       </p:sp>
@@ -14489,6 +14813,87 @@
           </a:p>
         </p:txBody>
       </p:sp>
+      <p:sp>
+        <p:nvSpPr>
+          <p:cNvPr id="9001" name="TextAnalogyLabel"/>
+          <p:cNvSpPr txBox="1"/>
+          <p:nvPr/>
+        </p:nvSpPr>
+        <p:spPr>
+          <a:xfrm>
+            <a:off x="548640" y="5857160"/>
+            <a:ext cx="11094415" cy="182880"/>
+          </a:xfrm>
+          <a:prstGeom prst="rect">
+            <a:avLst/>
+          </a:prstGeom>
+          <a:noFill/>
+          <a:ln/>
+        </p:spPr>
+        <p:txBody>
+          <a:bodyPr wrap="square" lIns="0" tIns="0" rIns="0" bIns="0" rtlCol="0" anchor="t"/>
+          <a:lstStyle/>
+          <a:p>
+            <a:pPr indent="0" marL="0">
+              <a:buNone/>
+            </a:pPr>
+            <a:r>
+              <a:rPr lang="en-US" sz="950" b="1" spc="100" kern="0" dirty="0">
+                <a:solidFill>
+                  <a:srgbClr val="0E7A8C"/>
+                </a:solidFill>
+                <a:latin typeface="Calibri" pitchFamily="34" charset="0"/>
+                <a:ea typeface="Calibri" pitchFamily="34" charset="-122"/>
+                <a:cs typeface="Calibri" pitchFamily="34" charset="-120"/>
+              </a:rPr>
+              <a:t>ПРОСТЫМИ СЛОВАМИ</a:t>
+            </a:r>
+            <a:endParaRPr lang="en-US" sz="950" dirty="0"/>
+          </a:p>
+        </p:txBody>
+      </p:sp>
+      <p:sp>
+        <p:nvSpPr>
+          <p:cNvPr id="9002" name="TextAnalogyBody"/>
+          <p:cNvSpPr txBox="1"/>
+          <p:nvPr/>
+        </p:nvSpPr>
+        <p:spPr>
+          <a:xfrm>
+            <a:off x="548640" y="6060040"/>
+            <a:ext cx="11094415" cy="600000"/>
+          </a:xfrm>
+          <a:prstGeom prst="rect">
+            <a:avLst/>
+          </a:prstGeom>
+          <a:noFill/>
+          <a:ln/>
+        </p:spPr>
+        <p:txBody>
+          <a:bodyPr wrap="square" lIns="0" tIns="0" rIns="0" bIns="0" rtlCol="0" anchor="t"/>
+          <a:lstStyle/>
+          <a:p>
+            <a:pPr indent="0" marL="0">
+              <a:lnSpc>
+                <a:spcPts val="1400"/>
+              </a:lnSpc>
+              <a:buNone/>
+            </a:pPr>
+            <a:r>
+              <a:rPr lang="en-US" sz="1100" i="1" dirty="0">
+                <a:solidFill>
+                  <a:srgbClr val="6B7680"/>
+                </a:solidFill>
+                <a:latin typeface="Calibri" pitchFamily="34" charset="0"/>
+                <a:ea typeface="Calibri" pitchFamily="34" charset="-122"/>
+                <a:cs typeface="Calibri" pitchFamily="34" charset="-120"/>
+              </a:rPr>
+              <a:t>Тут как в офисе с несколькими похожими дверьми подряд: одна ведёт в кабинет «кто вообще может войти в саму админку», другая — в кабинет «кому что разрешено внутри чата»; дверь на вид та же, а комнаты за ней разные — частая причина путаницы.</a:t>
+            </a:r>
+            <a:endParaRPr lang="en-US" sz="1100" dirty="0"/>
+          </a:p>
+        </p:txBody>
+      </p:sp>
     </p:spTree>
   </p:cSld>
   <p:clrMapOvr>
@@ -15512,6 +15917,87 @@
           </a:p>
         </p:txBody>
       </p:sp>
+      <p:sp>
+        <p:nvSpPr>
+          <p:cNvPr id="9001" name="TextAnalogyLabel"/>
+          <p:cNvSpPr txBox="1"/>
+          <p:nvPr/>
+        </p:nvSpPr>
+        <p:spPr>
+          <a:xfrm>
+            <a:off x="548640" y="5857160"/>
+            <a:ext cx="11094415" cy="182880"/>
+          </a:xfrm>
+          <a:prstGeom prst="rect">
+            <a:avLst/>
+          </a:prstGeom>
+          <a:noFill/>
+          <a:ln/>
+        </p:spPr>
+        <p:txBody>
+          <a:bodyPr wrap="square" lIns="0" tIns="0" rIns="0" bIns="0" rtlCol="0" anchor="t"/>
+          <a:lstStyle/>
+          <a:p>
+            <a:pPr indent="0" marL="0">
+              <a:buNone/>
+            </a:pPr>
+            <a:r>
+              <a:rPr lang="en-US" sz="950" b="1" spc="100" kern="0" dirty="0">
+                <a:solidFill>
+                  <a:srgbClr val="0E7A8C"/>
+                </a:solidFill>
+                <a:latin typeface="Calibri" pitchFamily="34" charset="0"/>
+                <a:ea typeface="Calibri" pitchFamily="34" charset="-122"/>
+                <a:cs typeface="Calibri" pitchFamily="34" charset="-120"/>
+              </a:rPr>
+              <a:t>ПРОСТЫМИ СЛОВАМИ</a:t>
+            </a:r>
+            <a:endParaRPr lang="en-US" sz="950" dirty="0"/>
+          </a:p>
+        </p:txBody>
+      </p:sp>
+      <p:sp>
+        <p:nvSpPr>
+          <p:cNvPr id="9002" name="TextAnalogyBody"/>
+          <p:cNvSpPr txBox="1"/>
+          <p:nvPr/>
+        </p:nvSpPr>
+        <p:spPr>
+          <a:xfrm>
+            <a:off x="548640" y="6060040"/>
+            <a:ext cx="11094415" cy="600000"/>
+          </a:xfrm>
+          <a:prstGeom prst="rect">
+            <a:avLst/>
+          </a:prstGeom>
+          <a:noFill/>
+          <a:ln/>
+        </p:spPr>
+        <p:txBody>
+          <a:bodyPr wrap="square" lIns="0" tIns="0" rIns="0" bIns="0" rtlCol="0" anchor="t"/>
+          <a:lstStyle/>
+          <a:p>
+            <a:pPr indent="0" marL="0">
+              <a:lnSpc>
+                <a:spcPts val="1400"/>
+              </a:lnSpc>
+              <a:buNone/>
+            </a:pPr>
+            <a:r>
+              <a:rPr lang="en-US" sz="1100" i="1" dirty="0">
+                <a:solidFill>
+                  <a:srgbClr val="6B7680"/>
+                </a:solidFill>
+                <a:latin typeface="Calibri" pitchFamily="34" charset="0"/>
+                <a:ea typeface="Calibri" pitchFamily="34" charset="-122"/>
+                <a:cs typeface="Calibri" pitchFamily="34" charset="-120"/>
+              </a:rPr>
+              <a:t>Как отдельный сейф в той же компании: не там же, где обычные документы, а специально для того, что нельзя показывать наружу — с отдельной охраной и отдельными правилами.</a:t>
+            </a:r>
+            <a:endParaRPr lang="en-US" sz="1100" dirty="0"/>
+          </a:p>
+        </p:txBody>
+      </p:sp>
     </p:spTree>
   </p:cSld>
   <p:clrMapOvr>
@@ -25629,6 +26115,87 @@
           </a:ln>
         </p:spPr>
       </p:sp>
+      <p:sp>
+        <p:nvSpPr>
+          <p:cNvPr id="9001" name="TextAnalogyLabel"/>
+          <p:cNvSpPr txBox="1"/>
+          <p:nvPr/>
+        </p:nvSpPr>
+        <p:spPr>
+          <a:xfrm>
+            <a:off x="548640" y="5760720"/>
+            <a:ext cx="11094415" cy="182880"/>
+          </a:xfrm>
+          <a:prstGeom prst="rect">
+            <a:avLst/>
+          </a:prstGeom>
+          <a:noFill/>
+          <a:ln/>
+        </p:spPr>
+        <p:txBody>
+          <a:bodyPr wrap="square" lIns="0" tIns="0" rIns="0" bIns="0" rtlCol="0" anchor="t"/>
+          <a:lstStyle/>
+          <a:p>
+            <a:pPr indent="0" marL="0">
+              <a:buNone/>
+            </a:pPr>
+            <a:r>
+              <a:rPr lang="en-US" sz="950" b="1" spc="100" kern="0" dirty="0">
+                <a:solidFill>
+                  <a:srgbClr val="0E7A8C"/>
+                </a:solidFill>
+                <a:latin typeface="Calibri" pitchFamily="34" charset="0"/>
+                <a:ea typeface="Calibri" pitchFamily="34" charset="-122"/>
+                <a:cs typeface="Calibri" pitchFamily="34" charset="-120"/>
+              </a:rPr>
+              <a:t>ПРОСТЫМИ СЛОВАМИ</a:t>
+            </a:r>
+            <a:endParaRPr lang="en-US" sz="950" dirty="0"/>
+          </a:p>
+        </p:txBody>
+      </p:sp>
+      <p:sp>
+        <p:nvSpPr>
+          <p:cNvPr id="9002" name="TextAnalogyBody"/>
+          <p:cNvSpPr txBox="1"/>
+          <p:nvPr/>
+        </p:nvSpPr>
+        <p:spPr>
+          <a:xfrm>
+            <a:off x="548640" y="5989320"/>
+            <a:ext cx="11094415" cy="600000"/>
+          </a:xfrm>
+          <a:prstGeom prst="rect">
+            <a:avLst/>
+          </a:prstGeom>
+          <a:noFill/>
+          <a:ln/>
+        </p:spPr>
+        <p:txBody>
+          <a:bodyPr wrap="square" lIns="0" tIns="0" rIns="0" bIns="0" rtlCol="0" anchor="t"/>
+          <a:lstStyle/>
+          <a:p>
+            <a:pPr indent="0" marL="0">
+              <a:lnSpc>
+                <a:spcPts val="1400"/>
+              </a:lnSpc>
+              <a:buNone/>
+            </a:pPr>
+            <a:r>
+              <a:rPr lang="en-US" sz="1100" i="1" dirty="0">
+                <a:solidFill>
+                  <a:srgbClr val="6B7680"/>
+                </a:solidFill>
+                <a:latin typeface="Calibri" pitchFamily="34" charset="0"/>
+                <a:ea typeface="Calibri" pitchFamily="34" charset="-122"/>
+                <a:cs typeface="Calibri" pitchFamily="34" charset="-120"/>
+              </a:rPr>
+              <a:t>Представьте очень начитанного коллегу, который перед каждым ответом сначала идёт в архив и перечитывает нужные документы, а потом честно говорит: «вот что нашёл» или «в документах об этом ничего нет» — вместо того чтобы отвечать по памяти и на удачу.</a:t>
+            </a:r>
+            <a:endParaRPr lang="en-US" sz="1100" dirty="0"/>
+          </a:p>
+        </p:txBody>
+      </p:sp>
     </p:spTree>
   </p:cSld>
   <p:clrMapOvr>
@@ -29004,6 +29571,87 @@
           </a:p>
         </p:txBody>
       </p:sp>
+      <p:sp>
+        <p:nvSpPr>
+          <p:cNvPr id="9001" name="TextAnalogyLabel"/>
+          <p:cNvSpPr txBox="1"/>
+          <p:nvPr/>
+        </p:nvSpPr>
+        <p:spPr>
+          <a:xfrm>
+            <a:off x="548640" y="5696712"/>
+            <a:ext cx="11094415" cy="182880"/>
+          </a:xfrm>
+          <a:prstGeom prst="rect">
+            <a:avLst/>
+          </a:prstGeom>
+          <a:noFill/>
+          <a:ln/>
+        </p:spPr>
+        <p:txBody>
+          <a:bodyPr wrap="square" lIns="0" tIns="0" rIns="0" bIns="0" rtlCol="0" anchor="t"/>
+          <a:lstStyle/>
+          <a:p>
+            <a:pPr indent="0" marL="0">
+              <a:buNone/>
+            </a:pPr>
+            <a:r>
+              <a:rPr lang="en-US" sz="950" b="1" spc="100" kern="0" dirty="0">
+                <a:solidFill>
+                  <a:srgbClr val="0E7A8C"/>
+                </a:solidFill>
+                <a:latin typeface="Calibri" pitchFamily="34" charset="0"/>
+                <a:ea typeface="Calibri" pitchFamily="34" charset="-122"/>
+                <a:cs typeface="Calibri" pitchFamily="34" charset="-120"/>
+              </a:rPr>
+              <a:t>ПРОСТЫМИ СЛОВАМИ</a:t>
+            </a:r>
+            <a:endParaRPr lang="en-US" sz="950" dirty="0"/>
+          </a:p>
+        </p:txBody>
+      </p:sp>
+      <p:sp>
+        <p:nvSpPr>
+          <p:cNvPr id="9002" name="TextAnalogyBody"/>
+          <p:cNvSpPr txBox="1"/>
+          <p:nvPr/>
+        </p:nvSpPr>
+        <p:spPr>
+          <a:xfrm>
+            <a:off x="548640" y="5925312"/>
+            <a:ext cx="11094415" cy="600000"/>
+          </a:xfrm>
+          <a:prstGeom prst="rect">
+            <a:avLst/>
+          </a:prstGeom>
+          <a:noFill/>
+          <a:ln/>
+        </p:spPr>
+        <p:txBody>
+          <a:bodyPr wrap="square" lIns="0" tIns="0" rIns="0" bIns="0" rtlCol="0" anchor="t"/>
+          <a:lstStyle/>
+          <a:p>
+            <a:pPr indent="0" marL="0">
+              <a:lnSpc>
+                <a:spcPts val="1400"/>
+              </a:lnSpc>
+              <a:buNone/>
+            </a:pPr>
+            <a:r>
+              <a:rPr lang="en-US" sz="1100" i="1" dirty="0">
+                <a:solidFill>
+                  <a:srgbClr val="6B7680"/>
+                </a:solidFill>
+                <a:latin typeface="Calibri" pitchFamily="34" charset="0"/>
+                <a:ea typeface="Calibri" pitchFamily="34" charset="-122"/>
+                <a:cs typeface="Calibri" pitchFamily="34" charset="-120"/>
+              </a:rPr>
+              <a:t>Это как переписка с коллегой в мессенджере — только коллега перед каждым ответом сначала открывает нужные папки с документами компании, а внизу сообщения честно указывает, откуда взял информацию.</a:t>
+            </a:r>
+            <a:endParaRPr lang="en-US" sz="1100" dirty="0"/>
+          </a:p>
+        </p:txBody>
+      </p:sp>
     </p:spTree>
   </p:cSld>
   <p:clrMapOvr>
@@ -29960,6 +30608,87 @@
           </a:p>
         </p:txBody>
       </p:sp>
+      <p:sp>
+        <p:nvSpPr>
+          <p:cNvPr id="9001" name="TextAnalogyLabel"/>
+          <p:cNvSpPr txBox="1"/>
+          <p:nvPr/>
+        </p:nvSpPr>
+        <p:spPr>
+          <a:xfrm>
+            <a:off x="548640" y="5669280"/>
+            <a:ext cx="11094415" cy="182880"/>
+          </a:xfrm>
+          <a:prstGeom prst="rect">
+            <a:avLst/>
+          </a:prstGeom>
+          <a:noFill/>
+          <a:ln/>
+        </p:spPr>
+        <p:txBody>
+          <a:bodyPr wrap="square" lIns="0" tIns="0" rIns="0" bIns="0" rtlCol="0" anchor="t"/>
+          <a:lstStyle/>
+          <a:p>
+            <a:pPr indent="0" marL="0">
+              <a:buNone/>
+            </a:pPr>
+            <a:r>
+              <a:rPr lang="en-US" sz="950" b="1" spc="100" kern="0" dirty="0">
+                <a:solidFill>
+                  <a:srgbClr val="0E7A8C"/>
+                </a:solidFill>
+                <a:latin typeface="Calibri" pitchFamily="34" charset="0"/>
+                <a:ea typeface="Calibri" pitchFamily="34" charset="-122"/>
+                <a:cs typeface="Calibri" pitchFamily="34" charset="-120"/>
+              </a:rPr>
+              <a:t>ПРОСТЫМИ СЛОВАМИ</a:t>
+            </a:r>
+            <a:endParaRPr lang="en-US" sz="950" dirty="0"/>
+          </a:p>
+        </p:txBody>
+      </p:sp>
+      <p:sp>
+        <p:nvSpPr>
+          <p:cNvPr id="9002" name="TextAnalogyBody"/>
+          <p:cNvSpPr txBox="1"/>
+          <p:nvPr/>
+        </p:nvSpPr>
+        <p:spPr>
+          <a:xfrm>
+            <a:off x="548640" y="5897880"/>
+            <a:ext cx="11094415" cy="600000"/>
+          </a:xfrm>
+          <a:prstGeom prst="rect">
+            <a:avLst/>
+          </a:prstGeom>
+          <a:noFill/>
+          <a:ln/>
+        </p:spPr>
+        <p:txBody>
+          <a:bodyPr wrap="square" lIns="0" tIns="0" rIns="0" bIns="0" rtlCol="0" anchor="t"/>
+          <a:lstStyle/>
+          <a:p>
+            <a:pPr indent="0" marL="0">
+              <a:lnSpc>
+                <a:spcPts val="1400"/>
+              </a:lnSpc>
+              <a:buNone/>
+            </a:pPr>
+            <a:r>
+              <a:rPr lang="en-US" sz="1100" i="1" dirty="0">
+                <a:solidFill>
+                  <a:srgbClr val="6B7680"/>
+                </a:solidFill>
+                <a:latin typeface="Calibri" pitchFamily="34" charset="0"/>
+                <a:ea typeface="Calibri" pitchFamily="34" charset="-122"/>
+                <a:cs typeface="Calibri" pitchFamily="34" charset="-120"/>
+              </a:rPr>
+              <a:t>Как папка «Готовые ответы» у секретаря: на часто повторяющийся вопрос не пишут ответ заново каждый раз, а достают проверенный шаблон и вписывают туда свежие цифры.</a:t>
+            </a:r>
+            <a:endParaRPr lang="en-US" sz="1100" dirty="0"/>
+          </a:p>
+        </p:txBody>
+      </p:sp>
     </p:spTree>
   </p:cSld>
   <p:clrMapOvr>
@@ -31978,6 +32707,87 @@
           </a:p>
         </p:txBody>
       </p:sp>
+      <p:sp>
+        <p:nvSpPr>
+          <p:cNvPr id="9001" name="TextAnalogyLabel"/>
+          <p:cNvSpPr txBox="1"/>
+          <p:nvPr/>
+        </p:nvSpPr>
+        <p:spPr>
+          <a:xfrm>
+            <a:off x="548640" y="5669280"/>
+            <a:ext cx="11094415" cy="182880"/>
+          </a:xfrm>
+          <a:prstGeom prst="rect">
+            <a:avLst/>
+          </a:prstGeom>
+          <a:noFill/>
+          <a:ln/>
+        </p:spPr>
+        <p:txBody>
+          <a:bodyPr wrap="square" lIns="0" tIns="0" rIns="0" bIns="0" rtlCol="0" anchor="t"/>
+          <a:lstStyle/>
+          <a:p>
+            <a:pPr indent="0" marL="0">
+              <a:buNone/>
+            </a:pPr>
+            <a:r>
+              <a:rPr lang="en-US" sz="950" b="1" spc="100" kern="0" dirty="0">
+                <a:solidFill>
+                  <a:srgbClr val="0E7A8C"/>
+                </a:solidFill>
+                <a:latin typeface="Calibri" pitchFamily="34" charset="0"/>
+                <a:ea typeface="Calibri" pitchFamily="34" charset="-122"/>
+                <a:cs typeface="Calibri" pitchFamily="34" charset="-120"/>
+              </a:rPr>
+              <a:t>ПРОСТЫМИ СЛОВАМИ</a:t>
+            </a:r>
+            <a:endParaRPr lang="en-US" sz="950" dirty="0"/>
+          </a:p>
+        </p:txBody>
+      </p:sp>
+      <p:sp>
+        <p:nvSpPr>
+          <p:cNvPr id="9002" name="TextAnalogyBody"/>
+          <p:cNvSpPr txBox="1"/>
+          <p:nvPr/>
+        </p:nvSpPr>
+        <p:spPr>
+          <a:xfrm>
+            <a:off x="548640" y="5897880"/>
+            <a:ext cx="11094415" cy="600000"/>
+          </a:xfrm>
+          <a:prstGeom prst="rect">
+            <a:avLst/>
+          </a:prstGeom>
+          <a:noFill/>
+          <a:ln/>
+        </p:spPr>
+        <p:txBody>
+          <a:bodyPr wrap="square" lIns="0" tIns="0" rIns="0" bIns="0" rtlCol="0" anchor="t"/>
+          <a:lstStyle/>
+          <a:p>
+            <a:pPr indent="0" marL="0">
+              <a:lnSpc>
+                <a:spcPts val="1400"/>
+              </a:lnSpc>
+              <a:buNone/>
+            </a:pPr>
+            <a:r>
+              <a:rPr lang="en-US" sz="1100" i="1" dirty="0">
+                <a:solidFill>
+                  <a:srgbClr val="6B7680"/>
+                </a:solidFill>
+                <a:latin typeface="Calibri" pitchFamily="34" charset="0"/>
+                <a:ea typeface="Calibri" pitchFamily="34" charset="-122"/>
+                <a:cs typeface="Calibri" pitchFamily="34" charset="-120"/>
+              </a:rPr>
+              <a:t>Это картотека библиотеки: видно, какие «книги» сдали на полку, какие уже расставлены по разделам (проиндексированы), а какие ещё обрабатываются.</a:t>
+            </a:r>
+            <a:endParaRPr lang="en-US" sz="1100" dirty="0"/>
+          </a:p>
+        </p:txBody>
+      </p:sp>
     </p:spTree>
   </p:cSld>
   <p:clrMapOvr>
@@ -33189,6 +33999,87 @@
               <a:t>ролевые системные промпты чата</a:t>
             </a:r>
             <a:endParaRPr lang="en-US" sz="950" dirty="0"/>
+          </a:p>
+        </p:txBody>
+      </p:sp>
+      <p:sp>
+        <p:nvSpPr>
+          <p:cNvPr id="9001" name="TextAnalogyLabel"/>
+          <p:cNvSpPr txBox="1"/>
+          <p:nvPr/>
+        </p:nvSpPr>
+        <p:spPr>
+          <a:xfrm>
+            <a:off x="548640" y="4892040"/>
+            <a:ext cx="11094415" cy="182880"/>
+          </a:xfrm>
+          <a:prstGeom prst="rect">
+            <a:avLst/>
+          </a:prstGeom>
+          <a:noFill/>
+          <a:ln/>
+        </p:spPr>
+        <p:txBody>
+          <a:bodyPr wrap="square" lIns="0" tIns="0" rIns="0" bIns="0" rtlCol="0" anchor="t"/>
+          <a:lstStyle/>
+          <a:p>
+            <a:pPr indent="0" marL="0">
+              <a:buNone/>
+            </a:pPr>
+            <a:r>
+              <a:rPr lang="en-US" sz="950" b="1" spc="100" kern="0" dirty="0">
+                <a:solidFill>
+                  <a:srgbClr val="0E7A8C"/>
+                </a:solidFill>
+                <a:latin typeface="Calibri" pitchFamily="34" charset="0"/>
+                <a:ea typeface="Calibri" pitchFamily="34" charset="-122"/>
+                <a:cs typeface="Calibri" pitchFamily="34" charset="-120"/>
+              </a:rPr>
+              <a:t>ПРОСТЫМИ СЛОВАМИ</a:t>
+            </a:r>
+            <a:endParaRPr lang="en-US" sz="950" dirty="0"/>
+          </a:p>
+        </p:txBody>
+      </p:sp>
+      <p:sp>
+        <p:nvSpPr>
+          <p:cNvPr id="9002" name="TextAnalogyBody"/>
+          <p:cNvSpPr txBox="1"/>
+          <p:nvPr/>
+        </p:nvSpPr>
+        <p:spPr>
+          <a:xfrm>
+            <a:off x="548640" y="5120640"/>
+            <a:ext cx="11094415" cy="600000"/>
+          </a:xfrm>
+          <a:prstGeom prst="rect">
+            <a:avLst/>
+          </a:prstGeom>
+          <a:noFill/>
+          <a:ln/>
+        </p:spPr>
+        <p:txBody>
+          <a:bodyPr wrap="square" lIns="0" tIns="0" rIns="0" bIns="0" rtlCol="0" anchor="t"/>
+          <a:lstStyle/>
+          <a:p>
+            <a:pPr indent="0" marL="0">
+              <a:lnSpc>
+                <a:spcPts val="1400"/>
+              </a:lnSpc>
+              <a:buNone/>
+            </a:pPr>
+            <a:r>
+              <a:rPr lang="en-US" sz="1100" i="1" dirty="0">
+                <a:solidFill>
+                  <a:srgbClr val="6B7680"/>
+                </a:solidFill>
+                <a:latin typeface="Calibri" pitchFamily="34" charset="0"/>
+                <a:ea typeface="Calibri" pitchFamily="34" charset="-122"/>
+                <a:cs typeface="Calibri" pitchFamily="34" charset="-120"/>
+              </a:rPr>
+              <a:t>Как стол входящих документов у руководителя: система сама готовит черновик правки (новый термин, новый агент), но подписывает и утверждает его всегда человек — само по себе в справочниках ничего не меняется.</a:t>
+            </a:r>
+            <a:endParaRPr lang="en-US" sz="1100" dirty="0"/>
           </a:p>
         </p:txBody>
       </p:sp>

</xml_diff>